<commit_message>
docs: presentation next steps lead with more scenarios
Co-Authored-By: Claude Sonnet 5 <noreply@anthropic.com>
</commit_message>
<xml_diff>
--- a/presentations/MANTIS_Presentation_2026-09-24.pptx
+++ b/presentations/MANTIS_Presentation_2026-09-24.pptx
@@ -1079,7 +1079,7 @@
           <a:lstStyle/>
           <a:p>
             <a:r>
-              <a:t>To close the technical part, here is the scope today and where it goes next. Today, ground truth is a declared baseline plus each plugin's own report, so MANTIS is a measurement instrument rather than an independent detector. Results use five trials per configuration and one model, gpt-oss-20b (open-weight), served through UF Navigator. The data and backend are synthetic and sandboxed. Scoring covers actions and outcomes, with database snapshots for data-level effects. And the defenses cover the gaps we measured. Where it goes next follows naturally from that. Larger campaigns along the same axes to tighten the numbers. More models, so results can be compared across model families. More institution profiles and workflow patterns. And a place to evaluate other people's guardrails through the same framework, against the same attacks.</a:t>
+              <a:t>To close the technical part, here is the scope today and where it goes next. Today, ground truth is a declared baseline plus each plugin's own report, so MANTIS is a measurement instrument rather than an independent detector. Results use five trials per configuration and one model, gpt-oss-20b (open-weight), served through UF Navigator. The data and backend are synthetic and sandboxed. Scoring covers actions and outcomes, with database snapshots for data-level effects. And the defenses cover the gaps we measured. Where it goes next follows naturally from that. The main direction is more scenarios: we already grew the library to nineteen baselines and twenty-six attack variants without changing the architecture, and the same recipe, a new prompt or config over the existing agents, tools and seeded data, adds more workflows, more attack variants, and more measured baselines. Then larger campaigns along the same axes to tighten the numbers. More models, so results can be compared across model families. More institution profiles and workflow patterns. And a place to evaluate other people's guardrails through the same framework, against the same attacks.</a:t>
             </a:r>
           </a:p>
         </p:txBody>
@@ -13439,6 +13439,25 @@
                 </a:solidFill>
                 <a:latin typeface="Arial"/>
               </a:rPr>
+              <a:t>More scenarios: new banking workflows, more attack variants and more measured baselines, each added as a config over the same architecture.</a:t>
+            </a:r>
+          </a:p>
+          <a:p>
+            <a:pPr algn="l">
+              <a:lnSpc>
+                <a:spcPct val="108000"/>
+              </a:lnSpc>
+              <a:spcAft>
+                <a:spcPts val="900"/>
+              </a:spcAft>
+            </a:pPr>
+            <a:r>
+              <a:rPr sz="1400" b="0">
+                <a:solidFill>
+                  <a:srgbClr val="FFFFFF"/>
+                </a:solidFill>
+                <a:latin typeface="Arial"/>
+              </a:rPr>
               <a:t>Larger campaigns along the same axes, to tighten the numbers.</a:t>
             </a:r>
           </a:p>

</xml_diff>

<commit_message>
docs: demo slide shows the current attacks and how to see results
Co-Authored-By: Claude Sonnet 5 <noreply@anthropic.com>
</commit_message>
<xml_diff>
--- a/presentations/MANTIS_Presentation_2026-09-24.pptx
+++ b/presentations/MANTIS_Presentation_2026-09-24.pptx
@@ -1009,7 +1009,7 @@
           <a:lstStyle/>
           <a:p>
             <a:r>
-              <a:t>If we have time, here is a five-minute live demo with four commands. First, inventory: it introspects the live system and lists agents, tools, and domains. Second, run the route-confusion attack and evaluate it. The attack fires, and the scorecard flags that the outcome diverged from the recorded baseline. Third, run the same attack with the routing guard switched on. The attack still fires, the guard restores the compliant route, and the run ends in manual review, like the baseline. Fourth, open the trace viewer on both runs and compare them side by side. The checklist on the right is what I have in place before we start. If the model is slow, I have the recorded runs ready to open in the UI, so the demo does not depend on a live call.</a:t>
+              <a:t>Now a short live demo of the attacks that are already built in, and how you see what they did. First, inventory: it introspects the live system and lists agents, tools, and domains. Second, I run three of the current attacks with one command each: route confusion, funds-transfer mutation, and prompt injection. Each one fires against the real banking system and a live model. Third, this is how you see the result. Every run leaves a scorecard: did the attack fire, did the outcome change, and which checkpoints were reached. I can open it as a table in the trace viewer, or read it straight from the evaluation file. Fourth, I run the same route-confusion attack with the routing guard switched on, and we compare the two runs side by side. The checklist on the right is what I have in place. If the model is slow, I have recorded runs ready to open, so the demo does not depend on a live call.</a:t>
             </a:r>
           </a:p>
         </p:txBody>
@@ -12286,7 +12286,7 @@
                 </a:solidFill>
                 <a:latin typeface="Arial"/>
               </a:rPr>
-              <a:t>See it run: five minutes, four commands</a:t>
+              <a:t>See it run: the current attacks, and how to see the result</a:t>
             </a:r>
           </a:p>
         </p:txBody>
@@ -12368,7 +12368,7 @@
           <a:p>
             <a:pPr algn="l">
               <a:lnSpc>
-                <a:spcPct val="110000"/>
+                <a:spcPct val="108000"/>
               </a:lnSpc>
               <a:spcAft>
                 <a:spcPts val="0"/>
@@ -12394,8 +12394,8 @@
         </p:nvSpPr>
         <p:spPr>
           <a:xfrm>
-            <a:off x="1234440" y="1737360"/>
-            <a:ext cx="6126480" cy="457200"/>
+            <a:off x="1234440" y="1755648"/>
+            <a:ext cx="6126480" cy="640080"/>
           </a:xfrm>
           <a:prstGeom prst="rect">
             <a:avLst/>
@@ -12423,7 +12423,7 @@
                 </a:solidFill>
                 <a:latin typeface="Arial"/>
               </a:rPr>
-              <a:t>Live list of agents, tools and domains — introspected, not hand-maintained.</a:t>
+              <a:t>Live list of agents, tools and domains.</a:t>
             </a:r>
           </a:p>
         </p:txBody>
@@ -12490,7 +12490,7 @@
         <p:spPr>
           <a:xfrm>
             <a:off x="1234440" y="2423160"/>
-            <a:ext cx="6126480" cy="530352"/>
+            <a:ext cx="6126480" cy="292608"/>
           </a:xfrm>
           <a:prstGeom prst="rect">
             <a:avLst/>
@@ -12505,7 +12505,7 @@
           <a:p>
             <a:pPr algn="l">
               <a:lnSpc>
-                <a:spcPct val="110000"/>
+                <a:spcPct val="108000"/>
               </a:lnSpc>
               <a:spcAft>
                 <a:spcPts val="0"/>
@@ -12518,8 +12518,7 @@
                 </a:solidFill>
                 <a:latin typeface="Courier New"/>
               </a:rPr>
-              <a:t>mantis --run configs/attacks/wp5_route_confusion.yaml
-mantis --evaluate run_artifacts/wp5_route_confusion</a:t>
+              <a:t>mantis --run &lt;attack&gt;.yaml   ×3</a:t>
             </a:r>
           </a:p>
         </p:txBody>
@@ -12532,8 +12531,8 @@
         </p:nvSpPr>
         <p:spPr>
           <a:xfrm>
-            <a:off x="1234440" y="2990088"/>
-            <a:ext cx="6126480" cy="457200"/>
+            <a:off x="1234440" y="2807208"/>
+            <a:ext cx="6126480" cy="640080"/>
           </a:xfrm>
           <a:prstGeom prst="rect">
             <a:avLst/>
@@ -12561,7 +12560,7 @@
                 </a:solidFill>
                 <a:latin typeface="Arial"/>
               </a:rPr>
-              <a:t>The attack fires; the scorecard flags the diverted outcome.</a:t>
+              <a:t>Route confusion, funds-transfer mutation, prompt injection — real agents, real backend.</a:t>
             </a:r>
           </a:p>
         </p:txBody>
@@ -12574,7 +12573,7 @@
         </p:nvSpPr>
         <p:spPr>
           <a:xfrm>
-            <a:off x="548640" y="3886200"/>
+            <a:off x="548640" y="3520439"/>
             <a:ext cx="502920" cy="502920"/>
           </a:xfrm>
           <a:prstGeom prst="ellipse">
@@ -12627,7 +12626,7 @@
         </p:nvSpPr>
         <p:spPr>
           <a:xfrm>
-            <a:off x="1234440" y="3840480"/>
+            <a:off x="1234440" y="3474720"/>
             <a:ext cx="6126480" cy="292608"/>
           </a:xfrm>
           <a:prstGeom prst="rect">
@@ -12643,7 +12642,7 @@
           <a:p>
             <a:pPr algn="l">
               <a:lnSpc>
-                <a:spcPct val="110000"/>
+                <a:spcPct val="108000"/>
               </a:lnSpc>
               <a:spcAft>
                 <a:spcPts val="0"/>
@@ -12656,7 +12655,7 @@
                 </a:solidFill>
                 <a:latin typeface="Courier New"/>
               </a:rPr>
-              <a:t>mantis --run configs/extensions/guardrail_recovers_route_confusion.yaml</a:t>
+              <a:t>mantis --evaluate run_artifacts/&lt;run&gt;   ·   mantis --ui</a:t>
             </a:r>
           </a:p>
         </p:txBody>
@@ -12669,8 +12668,8 @@
         </p:nvSpPr>
         <p:spPr>
           <a:xfrm>
-            <a:off x="1234440" y="4206240"/>
-            <a:ext cx="6126480" cy="457200"/>
+            <a:off x="1234440" y="3858768"/>
+            <a:ext cx="6126480" cy="640080"/>
           </a:xfrm>
           <a:prstGeom prst="rect">
             <a:avLst/>
@@ -12698,7 +12697,7 @@
                 </a:solidFill>
                 <a:latin typeface="Arial"/>
               </a:rPr>
-              <a:t>Same attack, guard on: it redirects, and the run ends in manual review.</a:t>
+              <a:t>See it: fired, effect vs baseline, hook coverage — as a scorecard and in the trace viewer.</a:t>
             </a:r>
           </a:p>
         </p:txBody>
@@ -12711,7 +12710,7 @@
         </p:nvSpPr>
         <p:spPr>
           <a:xfrm>
-            <a:off x="548640" y="4937759"/>
+            <a:off x="548640" y="4800600"/>
             <a:ext cx="502920" cy="502920"/>
           </a:xfrm>
           <a:prstGeom prst="ellipse">
@@ -12764,7 +12763,7 @@
         </p:nvSpPr>
         <p:spPr>
           <a:xfrm>
-            <a:off x="1234440" y="4892040"/>
+            <a:off x="1234440" y="4754880"/>
             <a:ext cx="6126480" cy="292608"/>
           </a:xfrm>
           <a:prstGeom prst="rect">
@@ -12780,7 +12779,7 @@
           <a:p>
             <a:pPr algn="l">
               <a:lnSpc>
-                <a:spcPct val="110000"/>
+                <a:spcPct val="108000"/>
               </a:lnSpc>
               <a:spcAft>
                 <a:spcPts val="0"/>
@@ -12793,7 +12792,7 @@
                 </a:solidFill>
                 <a:latin typeface="Courier New"/>
               </a:rPr>
-              <a:t>mantis --ui</a:t>
+              <a:t>mantis --run &lt;attack + routing guard&gt;.yaml</a:t>
             </a:r>
           </a:p>
         </p:txBody>
@@ -12806,8 +12805,8 @@
         </p:nvSpPr>
         <p:spPr>
           <a:xfrm>
-            <a:off x="1234440" y="5257800"/>
-            <a:ext cx="6126480" cy="457200"/>
+            <a:off x="1234440" y="5138928"/>
+            <a:ext cx="6126480" cy="640080"/>
           </a:xfrm>
           <a:prstGeom prst="rect">
             <a:avLst/>
@@ -12835,7 +12834,7 @@
                 </a:solidFill>
                 <a:latin typeface="Arial"/>
               </a:rPr>
-              <a:t>Open the trace viewer on both runs and compare.</a:t>
+              <a:t>Same attack with the guard on: it redirects, and the run ends in manual review.</a:t>
             </a:r>
           </a:p>
         </p:txBody>

</xml_diff>

<commit_message>
docs: demo slide is one attack in five steps
Co-Authored-By: Claude Sonnet 5 <noreply@anthropic.com>
</commit_message>
<xml_diff>
--- a/presentations/MANTIS_Presentation_2026-09-24.pptx
+++ b/presentations/MANTIS_Presentation_2026-09-24.pptx
@@ -1009,7 +1009,7 @@
           <a:lstStyle/>
           <a:p>
             <a:r>
-              <a:t>Now a short live demo of the attacks that are already built in, and how you see what they did. First, inventory: it introspects the live system and lists agents, tools, and domains. Second, I run three of the current attacks with one command each: route confusion, funds-transfer mutation, and prompt injection. Each one fires against the real banking system and a live model. Third, this is how you see the result. Every run leaves a scorecard: did the attack fire, did the outcome change, and which checkpoints were reached. I can open it as a table in the trace viewer, or read it straight from the evaluation file. Fourth, I run the same route-confusion attack with the routing guard switched on, and we compare the two runs side by side. The checklist on the right is what I have in place. If the model is slow, I have recorded runs ready to open, so the demo does not depend on a live call.</a:t>
+              <a:t>Now a short live demo: how to run one of the built-in attacks and see what it did. It is five steps. Step one, open the project and activate the environment. Step two, run inventory. It introspects the live system and lists the agents, tools, and domains, so we know MANTIS sees the bank. Step three, run the route-confusion attack. This starts the real banking agents against the real backend and a live model, and injects the attack. Step four, evaluate the run. This scores the trace against the recorded baseline: did the attack fire, and did the outcome change. Step five, open the trace viewer in the browser. Every run appears in the list. I open this one and you can see the attack event in the trace, the scorecard, and which checkpoints were reached. In this run the attack fired and the workflow ended completed where manual review was expected, so the scorecard flags the diverted outcome. If the model is slow, I have this run recorded and ready to open, so the demo does not depend on a live call.</a:t>
             </a:r>
           </a:p>
         </p:txBody>
@@ -12286,7 +12286,7 @@
                 </a:solidFill>
                 <a:latin typeface="Arial"/>
               </a:rPr>
-              <a:t>See it run: the current attacks, and how to see the result</a:t>
+              <a:t>See it run: one attack, five steps</a:t>
             </a:r>
           </a:p>
         </p:txBody>
@@ -12353,7 +12353,7 @@
         <p:spPr>
           <a:xfrm>
             <a:off x="1234440" y="1371600"/>
-            <a:ext cx="6126480" cy="292608"/>
+            <a:ext cx="6309360" cy="292608"/>
           </a:xfrm>
           <a:prstGeom prst="rect">
             <a:avLst/>
@@ -12375,13 +12375,13 @@
               </a:spcAft>
             </a:pPr>
             <a:r>
-              <a:rPr sz="1100" b="0">
+              <a:rPr sz="1150" b="0">
                 <a:solidFill>
                   <a:srgbClr val="0E9AA7"/>
                 </a:solidFill>
                 <a:latin typeface="Courier New"/>
               </a:rPr>
-              <a:t>mantis --inventory</a:t>
+              <a:t>cd MANTIS &amp;&amp; source .venv/bin/activate</a:t>
             </a:r>
           </a:p>
         </p:txBody>
@@ -12394,8 +12394,8 @@
         </p:nvSpPr>
         <p:spPr>
           <a:xfrm>
-            <a:off x="1234440" y="1755648"/>
-            <a:ext cx="6126480" cy="640080"/>
+            <a:off x="1234440" y="1737360"/>
+            <a:ext cx="6309360" cy="502920"/>
           </a:xfrm>
           <a:prstGeom prst="rect">
             <a:avLst/>
@@ -12423,7 +12423,7 @@
                 </a:solidFill>
                 <a:latin typeface="Arial"/>
               </a:rPr>
-              <a:t>Live list of agents, tools and domains.</a:t>
+              <a:t>Open the project and activate the environment.</a:t>
             </a:r>
           </a:p>
         </p:txBody>
@@ -12436,7 +12436,7 @@
         </p:nvSpPr>
         <p:spPr>
           <a:xfrm>
-            <a:off x="548640" y="2468879"/>
+            <a:off x="548640" y="2423160"/>
             <a:ext cx="502920" cy="502920"/>
           </a:xfrm>
           <a:prstGeom prst="ellipse">
@@ -12489,8 +12489,8 @@
         </p:nvSpPr>
         <p:spPr>
           <a:xfrm>
-            <a:off x="1234440" y="2423160"/>
-            <a:ext cx="6126480" cy="292608"/>
+            <a:off x="1234440" y="2377440"/>
+            <a:ext cx="6309360" cy="292608"/>
           </a:xfrm>
           <a:prstGeom prst="rect">
             <a:avLst/>
@@ -12512,13 +12512,13 @@
               </a:spcAft>
             </a:pPr>
             <a:r>
-              <a:rPr sz="1100" b="0">
+              <a:rPr sz="1150" b="0">
                 <a:solidFill>
                   <a:srgbClr val="0E9AA7"/>
                 </a:solidFill>
                 <a:latin typeface="Courier New"/>
               </a:rPr>
-              <a:t>mantis --run &lt;attack&gt;.yaml   ×3</a:t>
+              <a:t>mantis --inventory</a:t>
             </a:r>
           </a:p>
         </p:txBody>
@@ -12531,8 +12531,8 @@
         </p:nvSpPr>
         <p:spPr>
           <a:xfrm>
-            <a:off x="1234440" y="2807208"/>
-            <a:ext cx="6126480" cy="640080"/>
+            <a:off x="1234440" y="2743200"/>
+            <a:ext cx="6309360" cy="502920"/>
           </a:xfrm>
           <a:prstGeom prst="rect">
             <a:avLst/>
@@ -12560,7 +12560,7 @@
                 </a:solidFill>
                 <a:latin typeface="Arial"/>
               </a:rPr>
-              <a:t>Route confusion, funds-transfer mutation, prompt injection — real agents, real backend.</a:t>
+              <a:t>Live list of the agents, tools and domains MANTIS sees.</a:t>
             </a:r>
           </a:p>
         </p:txBody>
@@ -12573,7 +12573,7 @@
         </p:nvSpPr>
         <p:spPr>
           <a:xfrm>
-            <a:off x="548640" y="3520439"/>
+            <a:off x="548640" y="3429000"/>
             <a:ext cx="502920" cy="502920"/>
           </a:xfrm>
           <a:prstGeom prst="ellipse">
@@ -12626,8 +12626,8 @@
         </p:nvSpPr>
         <p:spPr>
           <a:xfrm>
-            <a:off x="1234440" y="3474720"/>
-            <a:ext cx="6126480" cy="292608"/>
+            <a:off x="1234440" y="3383280"/>
+            <a:ext cx="6309360" cy="292608"/>
           </a:xfrm>
           <a:prstGeom prst="rect">
             <a:avLst/>
@@ -12649,13 +12649,13 @@
               </a:spcAft>
             </a:pPr>
             <a:r>
-              <a:rPr sz="1100" b="0">
+              <a:rPr sz="1150" b="0">
                 <a:solidFill>
                   <a:srgbClr val="0E9AA7"/>
                 </a:solidFill>
                 <a:latin typeface="Courier New"/>
               </a:rPr>
-              <a:t>mantis --evaluate run_artifacts/&lt;run&gt;   ·   mantis --ui</a:t>
+              <a:t>mantis --run configs/attacks/wp5_route_confusion.yaml</a:t>
             </a:r>
           </a:p>
         </p:txBody>
@@ -12668,8 +12668,8 @@
         </p:nvSpPr>
         <p:spPr>
           <a:xfrm>
-            <a:off x="1234440" y="3858768"/>
-            <a:ext cx="6126480" cy="640080"/>
+            <a:off x="1234440" y="3749040"/>
+            <a:ext cx="6309360" cy="502920"/>
           </a:xfrm>
           <a:prstGeom prst="rect">
             <a:avLst/>
@@ -12697,7 +12697,7 @@
                 </a:solidFill>
                 <a:latin typeface="Arial"/>
               </a:rPr>
-              <a:t>See it: fired, effect vs baseline, hook coverage — as a scorecard and in the trace viewer.</a:t>
+              <a:t>Run the attack: real agents, real backend, live model.</a:t>
             </a:r>
           </a:p>
         </p:txBody>
@@ -12710,7 +12710,7 @@
         </p:nvSpPr>
         <p:spPr>
           <a:xfrm>
-            <a:off x="548640" y="4800600"/>
+            <a:off x="548640" y="4434840"/>
             <a:ext cx="502920" cy="502920"/>
           </a:xfrm>
           <a:prstGeom prst="ellipse">
@@ -12763,8 +12763,8 @@
         </p:nvSpPr>
         <p:spPr>
           <a:xfrm>
-            <a:off x="1234440" y="4754880"/>
-            <a:ext cx="6126480" cy="292608"/>
+            <a:off x="1234440" y="4389120"/>
+            <a:ext cx="6309360" cy="292608"/>
           </a:xfrm>
           <a:prstGeom prst="rect">
             <a:avLst/>
@@ -12786,13 +12786,13 @@
               </a:spcAft>
             </a:pPr>
             <a:r>
-              <a:rPr sz="1100" b="0">
+              <a:rPr sz="1150" b="0">
                 <a:solidFill>
                   <a:srgbClr val="0E9AA7"/>
                 </a:solidFill>
                 <a:latin typeface="Courier New"/>
               </a:rPr>
-              <a:t>mantis --run &lt;attack + routing guard&gt;.yaml</a:t>
+              <a:t>mantis --evaluate run_artifacts/&lt;run&gt;</a:t>
             </a:r>
           </a:p>
         </p:txBody>
@@ -12805,8 +12805,8 @@
         </p:nvSpPr>
         <p:spPr>
           <a:xfrm>
-            <a:off x="1234440" y="5138928"/>
-            <a:ext cx="6126480" cy="640080"/>
+            <a:off x="1234440" y="4754880"/>
+            <a:ext cx="6309360" cy="502920"/>
           </a:xfrm>
           <a:prstGeom prst="rect">
             <a:avLst/>
@@ -12834,21 +12834,158 @@
                 </a:solidFill>
                 <a:latin typeface="Arial"/>
               </a:rPr>
-              <a:t>Same attack with the guard on: it redirects, and the run ends in manual review.</a:t>
-            </a:r>
-          </a:p>
-        </p:txBody>
-      </p:sp>
-      <p:sp>
-        <p:nvSpPr>
-          <p:cNvPr id="15" name="Rounded Rectangle 14"/>
+              <a:t>Score the run: did it fire, did the outcome change.</a:t>
+            </a:r>
+          </a:p>
+        </p:txBody>
+      </p:sp>
+      <p:sp>
+        <p:nvSpPr>
+          <p:cNvPr id="15" name="Oval 14"/>
           <p:cNvSpPr/>
           <p:nvPr/>
         </p:nvSpPr>
         <p:spPr>
           <a:xfrm>
-            <a:off x="7680960" y="1371600"/>
-            <a:ext cx="3959352" cy="4617720"/>
+            <a:off x="548640" y="5440680"/>
+            <a:ext cx="502920" cy="502920"/>
+          </a:xfrm>
+          <a:prstGeom prst="ellipse">
+            <a:avLst/>
+          </a:prstGeom>
+          <a:solidFill>
+            <a:srgbClr val="0E9AA7"/>
+          </a:solidFill>
+          <a:ln>
+            <a:noFill/>
+          </a:ln>
+          <a:effectLst/>
+        </p:spPr>
+        <p:style>
+          <a:lnRef idx="1">
+            <a:schemeClr val="accent1"/>
+          </a:lnRef>
+          <a:fillRef idx="3">
+            <a:schemeClr val="accent1"/>
+          </a:fillRef>
+          <a:effectRef idx="2">
+            <a:schemeClr val="accent1"/>
+          </a:effectRef>
+          <a:fontRef idx="minor">
+            <a:schemeClr val="lt1"/>
+          </a:fontRef>
+        </p:style>
+        <p:txBody>
+          <a:bodyPr rtlCol="0" anchor="ctr" lIns="0" rIns="0" tIns="0" bIns="0"/>
+          <a:lstStyle/>
+          <a:p>
+            <a:pPr algn="ctr"/>
+            <a:r>
+              <a:rPr sz="1600" b="1">
+                <a:solidFill>
+                  <a:srgbClr val="FFFFFF"/>
+                </a:solidFill>
+                <a:latin typeface="Arial"/>
+              </a:rPr>
+              <a:t>5</a:t>
+            </a:r>
+          </a:p>
+        </p:txBody>
+      </p:sp>
+      <p:sp>
+        <p:nvSpPr>
+          <p:cNvPr id="16" name="TextBox 15"/>
+          <p:cNvSpPr txBox="1"/>
+          <p:nvPr/>
+        </p:nvSpPr>
+        <p:spPr>
+          <a:xfrm>
+            <a:off x="1234440" y="5394960"/>
+            <a:ext cx="6309360" cy="292608"/>
+          </a:xfrm>
+          <a:prstGeom prst="rect">
+            <a:avLst/>
+          </a:prstGeom>
+          <a:noFill/>
+        </p:spPr>
+        <p:txBody>
+          <a:bodyPr wrap="square" lIns="0" rIns="0" tIns="0" bIns="0" anchor="t">
+            <a:spAutoFit/>
+          </a:bodyPr>
+          <a:lstStyle/>
+          <a:p>
+            <a:pPr algn="l">
+              <a:lnSpc>
+                <a:spcPct val="108000"/>
+              </a:lnSpc>
+              <a:spcAft>
+                <a:spcPts val="0"/>
+              </a:spcAft>
+            </a:pPr>
+            <a:r>
+              <a:rPr sz="1150" b="0">
+                <a:solidFill>
+                  <a:srgbClr val="0E9AA7"/>
+                </a:solidFill>
+                <a:latin typeface="Courier New"/>
+              </a:rPr>
+              <a:t>mantis --ui   →   http://127.0.0.1:8765</a:t>
+            </a:r>
+          </a:p>
+        </p:txBody>
+      </p:sp>
+      <p:sp>
+        <p:nvSpPr>
+          <p:cNvPr id="17" name="TextBox 16"/>
+          <p:cNvSpPr txBox="1"/>
+          <p:nvPr/>
+        </p:nvSpPr>
+        <p:spPr>
+          <a:xfrm>
+            <a:off x="1234440" y="5760720"/>
+            <a:ext cx="6309360" cy="502920"/>
+          </a:xfrm>
+          <a:prstGeom prst="rect">
+            <a:avLst/>
+          </a:prstGeom>
+          <a:noFill/>
+        </p:spPr>
+        <p:txBody>
+          <a:bodyPr wrap="square" lIns="0" rIns="0" tIns="0" bIns="0" anchor="t">
+            <a:spAutoFit/>
+          </a:bodyPr>
+          <a:lstStyle/>
+          <a:p>
+            <a:pPr algn="l">
+              <a:lnSpc>
+                <a:spcPct val="108000"/>
+              </a:lnSpc>
+              <a:spcAft>
+                <a:spcPts val="0"/>
+              </a:spcAft>
+            </a:pPr>
+            <a:r>
+              <a:rPr sz="1300" b="0">
+                <a:solidFill>
+                  <a:srgbClr val="12263F"/>
+                </a:solidFill>
+                <a:latin typeface="Arial"/>
+              </a:rPr>
+              <a:t>Open the trace viewer in the browser: trace, scorecard and hook coverage.</a:t>
+            </a:r>
+          </a:p>
+        </p:txBody>
+      </p:sp>
+      <p:sp>
+        <p:nvSpPr>
+          <p:cNvPr id="18" name="Rounded Rectangle 17"/>
+          <p:cNvSpPr/>
+          <p:nvPr/>
+        </p:nvSpPr>
+        <p:spPr>
+          <a:xfrm>
+            <a:off x="7863840" y="1371600"/>
+            <a:ext cx="3776472" cy="4846320"/>
           </a:xfrm>
           <a:prstGeom prst="roundRect">
             <a:avLst>
@@ -12885,14 +13022,14 @@
       </p:sp>
       <p:sp>
         <p:nvSpPr>
-          <p:cNvPr id="16" name="TextBox 15"/>
+          <p:cNvPr id="19" name="TextBox 18"/>
           <p:cNvSpPr txBox="1"/>
           <p:nvPr/>
         </p:nvSpPr>
         <p:spPr>
           <a:xfrm>
-            <a:off x="7955279" y="1554480"/>
-            <a:ext cx="3474720" cy="365760"/>
+            <a:off x="8092440" y="1554480"/>
+            <a:ext cx="3383280" cy="365760"/>
           </a:xfrm>
           <a:prstGeom prst="rect">
             <a:avLst/>
@@ -12920,21 +13057,21 @@
                 </a:solidFill>
                 <a:latin typeface="Arial"/>
               </a:rPr>
-              <a:t>BEFORE THE CALL</a:t>
-            </a:r>
-          </a:p>
-        </p:txBody>
-      </p:sp>
-      <p:sp>
-        <p:nvSpPr>
-          <p:cNvPr id="17" name="TextBox 16"/>
+              <a:t>WHAT YOU WILL SEE</a:t>
+            </a:r>
+          </a:p>
+        </p:txBody>
+      </p:sp>
+      <p:sp>
+        <p:nvSpPr>
+          <p:cNvPr id="20" name="TextBox 19"/>
           <p:cNvSpPr txBox="1"/>
           <p:nvPr/>
         </p:nvSpPr>
         <p:spPr>
           <a:xfrm>
-            <a:off x="7955279" y="1965960"/>
-            <a:ext cx="3520440" cy="3931920"/>
+            <a:off x="8092440" y="1965960"/>
+            <a:ext cx="3383280" cy="2194560"/>
           </a:xfrm>
           <a:prstGeom prst="rect">
             <a:avLst/>
@@ -12956,13 +13093,22 @@
               </a:spcAft>
             </a:pPr>
             <a:r>
-              <a:rPr sz="1400" b="0">
+              <a:rPr sz="1300" b="1">
+                <a:solidFill>
+                  <a:srgbClr val="F2A900"/>
+                </a:solidFill>
+                <a:latin typeface="Arial"/>
+              </a:rPr>
+              <a:t>Trace  </a:t>
+            </a:r>
+            <a:r>
+              <a:rPr sz="1300" b="0">
                 <a:solidFill>
                   <a:srgbClr val="FFFFFF"/>
                 </a:solidFill>
                 <a:latin typeface="Arial"/>
               </a:rPr>
-              <a:t>Activate the virtual environment.</a:t>
+              <a:t>an ATTACK_INJECTED event where the routing was hijacked</a:t>
             </a:r>
           </a:p>
           <a:p>
@@ -12975,51 +13121,153 @@
               </a:spcAft>
             </a:pPr>
             <a:r>
-              <a:rPr sz="1400" b="0">
+              <a:rPr sz="1300" b="1">
+                <a:solidFill>
+                  <a:srgbClr val="F2A900"/>
+                </a:solidFill>
+                <a:latin typeface="Arial"/>
+              </a:rPr>
+              <a:t>Scorecard  </a:t>
+            </a:r>
+            <a:r>
+              <a:rPr sz="1300" b="0">
                 <a:solidFill>
                   <a:srgbClr val="FFFFFF"/>
                 </a:solidFill>
                 <a:latin typeface="Arial"/>
               </a:rPr>
-              <a:t>Start the banking backend on port 8000.</a:t>
-            </a:r>
-          </a:p>
-          <a:p>
-            <a:pPr algn="l">
-              <a:lnSpc>
-                <a:spcPct val="108000"/>
-              </a:lnSpc>
-              <a:spcAft>
-                <a:spcPts val="1000"/>
-              </a:spcAft>
-            </a:pPr>
-            <a:r>
-              <a:rPr sz="1400" b="0">
+              <a:t>attack fired; outcome diverged from the baseline</a:t>
+            </a:r>
+          </a:p>
+          <a:p>
+            <a:pPr algn="l">
+              <a:lnSpc>
+                <a:spcPct val="108000"/>
+              </a:lnSpc>
+              <a:spcAft>
+                <a:spcPts val="0"/>
+              </a:spcAft>
+            </a:pPr>
+            <a:r>
+              <a:rPr sz="1300" b="1">
+                <a:solidFill>
+                  <a:srgbClr val="F2A900"/>
+                </a:solidFill>
+                <a:latin typeface="Arial"/>
+              </a:rPr>
+              <a:t>Hook coverage  </a:t>
+            </a:r>
+            <a:r>
+              <a:rPr sz="1300" b="0">
                 <a:solidFill>
                   <a:srgbClr val="FFFFFF"/>
                 </a:solidFill>
                 <a:latin typeface="Arial"/>
               </a:rPr>
-              <a:t>UF Navigator key in .env; confirm the endpoint is reachable from the network you present on.</a:t>
-            </a:r>
-          </a:p>
-          <a:p>
-            <a:pPr algn="l">
-              <a:lnSpc>
-                <a:spcPct val="108000"/>
-              </a:lnSpc>
-              <a:spcAft>
-                <a:spcPts val="1000"/>
-              </a:spcAft>
-            </a:pPr>
-            <a:r>
-              <a:rPr sz="1400" b="0">
+              <a:t>which checkpoints were reached</a:t>
+            </a:r>
+          </a:p>
+        </p:txBody>
+      </p:sp>
+      <p:sp>
+        <p:nvSpPr>
+          <p:cNvPr id="21" name="TextBox 20"/>
+          <p:cNvSpPr txBox="1"/>
+          <p:nvPr/>
+        </p:nvSpPr>
+        <p:spPr>
+          <a:xfrm>
+            <a:off x="8092440" y="4343400"/>
+            <a:ext cx="3383280" cy="320040"/>
+          </a:xfrm>
+          <a:prstGeom prst="rect">
+            <a:avLst/>
+          </a:prstGeom>
+          <a:noFill/>
+        </p:spPr>
+        <p:txBody>
+          <a:bodyPr wrap="square" lIns="0" rIns="0" tIns="0" bIns="0" anchor="t">
+            <a:spAutoFit/>
+          </a:bodyPr>
+          <a:lstStyle/>
+          <a:p>
+            <a:pPr algn="l">
+              <a:lnSpc>
+                <a:spcPct val="108000"/>
+              </a:lnSpc>
+              <a:spcAft>
+                <a:spcPts val="0"/>
+              </a:spcAft>
+            </a:pPr>
+            <a:r>
+              <a:rPr sz="1200" b="1">
+                <a:solidFill>
+                  <a:srgbClr val="F2A900"/>
+                </a:solidFill>
+                <a:latin typeface="Arial"/>
+              </a:rPr>
+              <a:t>BEFORE THE CALL</a:t>
+            </a:r>
+          </a:p>
+        </p:txBody>
+      </p:sp>
+      <p:sp>
+        <p:nvSpPr>
+          <p:cNvPr id="22" name="TextBox 21"/>
+          <p:cNvSpPr txBox="1"/>
+          <p:nvPr/>
+        </p:nvSpPr>
+        <p:spPr>
+          <a:xfrm>
+            <a:off x="8092440" y="4709160"/>
+            <a:ext cx="3383280" cy="1417320"/>
+          </a:xfrm>
+          <a:prstGeom prst="rect">
+            <a:avLst/>
+          </a:prstGeom>
+          <a:noFill/>
+        </p:spPr>
+        <p:txBody>
+          <a:bodyPr wrap="square" lIns="0" rIns="0" tIns="0" bIns="0" anchor="t">
+            <a:spAutoFit/>
+          </a:bodyPr>
+          <a:lstStyle/>
+          <a:p>
+            <a:pPr algn="l">
+              <a:lnSpc>
+                <a:spcPct val="108000"/>
+              </a:lnSpc>
+              <a:spcAft>
+                <a:spcPts val="600"/>
+              </a:spcAft>
+            </a:pPr>
+            <a:r>
+              <a:rPr sz="1200" b="0">
                 <a:solidFill>
                   <a:srgbClr val="FFFFFF"/>
                 </a:solidFill>
                 <a:latin typeface="Arial"/>
               </a:rPr>
-              <a:t>Fallback: open the checked-in run_artifacts folders in the UI — no live model call needed.</a:t>
+              <a:t>Backend running on port 8000; key in .env.</a:t>
+            </a:r>
+          </a:p>
+          <a:p>
+            <a:pPr algn="l">
+              <a:lnSpc>
+                <a:spcPct val="108000"/>
+              </a:lnSpc>
+              <a:spcAft>
+                <a:spcPts val="600"/>
+              </a:spcAft>
+            </a:pPr>
+            <a:r>
+              <a:rPr sz="1200" b="0">
+                <a:solidFill>
+                  <a:srgbClr val="FFFFFF"/>
+                </a:solidFill>
+                <a:latin typeface="Arial"/>
+              </a:rPr>
+              <a:t>Fallback: open the recorded run in the UI.</a:t>
             </a:r>
           </a:p>
           <a:p>
@@ -13032,13 +13280,13 @@
               </a:spcAft>
             </a:pPr>
             <a:r>
-              <a:rPr sz="1400" b="0">
+              <a:rPr sz="1200" b="0">
                 <a:solidFill>
                   <a:srgbClr val="9FB3C8"/>
                 </a:solidFill>
                 <a:latin typeface="Arial"/>
               </a:rPr>
-              <a:t>Demo data is synthetic; nothing touches a production system.</a:t>
+              <a:t>Synthetic data only.</a:t>
             </a:r>
           </a:p>
         </p:txBody>

</xml_diff>

<commit_message>
docs: deck notes written for a reader; drop the separate script files
Co-Authored-By: Claude Sonnet 5 <noreply@anthropic.com>
</commit_message>
<xml_diff>
--- a/presentations/MANTIS_Presentation_2026-09-24.pptx
+++ b/presentations/MANTIS_Presentation_2026-09-24.pptx
@@ -516,7 +516,7 @@
           <a:lstStyle/>
           <a:p>
             <a:r>
-              <a:t>Thanks for having us. This is MANTIS: a testbed where you attack a bank of AI agents on purpose, and know exactly what happened. In the next few minutes: what it is, how it's built, the attacks and results, how a new person gets started, and a short live demo. Everything runs on a realistic banking system with synthetic data.</a:t>
+              <a:t>MANTIS is a testbed for attacking a bank of AI agents on purpose and knowing exactly what happened. This deck covers what it is, how it is built, the attacks and results, how a newcomer gets started and extends it, and a short walkthrough of a run. Everything runs on a realistic banking system with synthetic data only.</a:t>
             </a:r>
           </a:p>
         </p:txBody>
@@ -586,7 +586,7 @@
           <a:lstStyle/>
           <a:p>
             <a:r>
-              <a:t>Defenses use the same mechanism as attacks, so you can compare them equally. We built six, covering all five categories of security mechanism in the plan. The rule is to re-check backend truth rather than trust the model. An amount limit, a routing guard that can redirect back to the compliant path, a batch integrity guard, response redaction, a rate limit, and action isolation. All six were verified live. This covers the gaps we measured; it is not a comprehensive defense suite.</a:t>
+              <a:t>Defenses use the same mechanism as attacks, so they can be compared on equal terms. Six were built, covering all five categories of security mechanism in the plan. The design rule is to re-check backend truth rather than trust the model's decision: an amount limit, a routing guard that can redirect back to the compliant path, a batch integrity guard, response redaction, a rate limit, and action isolation. All six were verified live. They cover the gaps that were measured and are not a comprehensive defense suite.</a:t>
             </a:r>
           </a:p>
         </p:txBody>
@@ -656,7 +656,7 @@
           <a:lstStyle/>
           <a:p>
             <a:r>
-              <a:t>To widen coverage we built a library on the same architecture: 19 measured baselines and 26 attack variants, 123 scored live trials, each starting from a fresh database and recording what changed. Four things stood out. Where an attack lands matters: the same payload changed the outcome in 1 of 5 trials at the monitor, but bypassed manual review in 5 of 5 at the decision agent. Silence can be the outcome: the SAR agent filed nothing 5 of 5 times. Data-level effects are invisible to tool-use scoring: in 20 of 20 trials the database changed while it flagged 0, which is why we record the database. And faults propagate through workflows. Read these as what happened in this sample, five trials per configuration, one model.</a:t>
+              <a:t>The extended library was built on the same architecture: 19 measured baselines and 26 attack variants, 123 scored live trials, each starting from a fresh database and recording what changed. Four findings stand out. Where an attack lands matters: the same payload changed the outcome in 1 of 5 trials at the monitor, but bypassed manual review in 5 of 5 at the decision agent. Silence can be the outcome: the injected SAR agent filed nothing 5 of 5 times. Data-level effects are invisible to tool-use scoring: in 20 of 20 trials the database changed while it flagged 0, which is why every trial records the database. Faults also propagate through workflows. These are counts from this sample: five trials per configuration and one model.</a:t>
             </a:r>
           </a:p>
         </p:txBody>
@@ -726,7 +726,7 @@
           <a:lstStyle/>
           <a:p>
             <a:r>
-              <a:t>Getting started is five steps. Clone and pip install. Add a model key to the environment file, or skip it: mock mode runs the whole pipeline with no key. Start the backend. Run inventory to confirm the install. Then run your first experiment with one command. The guide folder in the repository has every command written out.</a:t>
+              <a:t>Getting started takes five steps: clone and pip install; add a model key to the environment file, or skip it and use mock mode, which runs the whole pipeline with no key; start the backend; run inventory to confirm the install; and run a first experiment with one command. Four starter campaigns in configs/campaigns/ give a quick tour, and the GUIDE folder in the repository has every command written out.</a:t>
             </a:r>
           </a:p>
         </p:txBody>
@@ -796,7 +796,7 @@
           <a:lstStyle/>
           <a:p>
             <a:r>
-              <a:t>Adding an attack has two paths. Config only takes about two minutes: copy a config, change the target and parameters, then validate, run, evaluate. A brand-new plugin is about fifteen lines: a name, a control point, and one apply function. Register it with two lines, point a YAML at it, and run. I tried this from scratch: validated, run and scored in about ten seconds in mock mode with no key. You never touch the banking agents.</a:t>
+              <a:t>There are two paths. Config only takes about two minutes: copy a config, change the target and parameters, then validate, run and evaluate. A brand-new plugin is about fifteen lines: a name, a control point, and one apply function, registered with two lines and pointed at by a YAML file. Tried from scratch, this was validated, run and scored in about ten seconds in mock mode with no key. The banking agents are never touched.</a:t>
             </a:r>
           </a:p>
         </p:txBody>
@@ -866,7 +866,7 @@
           <a:lstStyle/>
           <a:p>
             <a:r>
-              <a:t>Now a short live demo of one built-in attack. Step one, open the project. Step two, inventory: it lists the agents, tools and domains MANTIS sees. Step three, run the route-confusion attack against the real system. Step four, evaluate: did it fire, did the outcome change. Step five, open the trace viewer in the browser. Pick the run, load the trace, and you can see the attack event, the scorecard, and which checkpoints fired. The attack fired and the workflow ended completed where manual review was expected. If the model is slow, I have this run recorded and ready.</a:t>
+              <a:t>A walkthrough of one built-in attack in five steps. Open the project; run inventory to list the agents, tools and domains MANTIS sees; run the route-confusion attack against the real system; evaluate to see whether it fired and whether the outcome changed; then open the trace viewer in the browser, pick the run, and load its trace, scorecard and hook coverage. In this run the attack fired and the workflow ended completed where manual review was expected, so the scorecard flags the diverted outcome.</a:t>
             </a:r>
           </a:p>
         </p:txBody>
@@ -936,7 +936,7 @@
           <a:lstStyle/>
           <a:p>
             <a:r>
-              <a:t>Scope today: ground truth is a declared baseline plus each plugin's own report, so this is a measurement instrument, not a detector. Results are five trials per configuration on one model, gpt-oss-20b (open-weight), served through UF Navigator, with synthetic data. Next: the main direction is more scenarios, new workflows, attack variants and baselines, added as configs over the same architecture. Then larger campaigns, more models, more institutions, and evaluating other teams' guardrails through the same framework. To sum up: a real system, five control points, plugins in YAML, automatic scoring, and a new person can run an experiment in minutes. Happy to take questions.</a:t>
+              <a:t>Scope today: ground truth is a declared baseline plus each plugin's own report, so MANTIS is a measurement instrument, not a detector. Results are five trials per configuration on one model, gpt-oss-20b (open-weight), served through UF Navigator, with synthetic data. Next: more scenarios (new workflows, attack variants and baselines added as configs over the same architecture), then larger campaigns, more models, more institutions, and evaluating other guardrails on the same framework. In short: a real system, five control points, plugins declared in YAML, automatic scoring, and a new person can run an experiment in minutes. The code and step-by-step guide are in the repository.</a:t>
             </a:r>
           </a:p>
         </p:txBody>
@@ -1006,7 +1006,7 @@
           <a:lstStyle/>
           <a:p>
             <a:r>
-              <a:t>Banks are splitting work across specialist AI agents, so every hand-off between agents is a new place for an attack or a failure. MANTIS tests that on purpose. One: the system under test is a real banking multi-agent system, and we never modify it. Two: an experiment is just a YAML file. Three: every run leaves evidence and an automatic verdict. To be clear, it's a testbed. It measures what an attack did. It is not a detector or a defense product.</a:t>
+              <a:t>Banks are splitting work across specialist AI agents, so every hand-off between agents is a new place for an attack or a failure. MANTIS tests that on purpose. The system under test is a real banking multi-agent system that is never modified. An experiment is a YAML file, and every run leaves evidence plus an automatic verdict. MANTIS is a testbed: it measures what an attack or fault did. It is not a detector or a defense product.</a:t>
             </a:r>
           </a:p>
         </p:txBody>
@@ -1076,7 +1076,7 @@
           <a:lstStyle/>
           <a:p>
             <a:r>
-              <a:t>The architecture is simple. Everything an agent does passes one of five checkpoints: request in, agent start, model call, tool action, result out. They sit on a hook bus, and any plugin can watch or change what passes. Attacks inject a fault, failures simulate ordinary faults, defenses deny or redact, and observability records everything, always last. At each checkpoint a plugin can continue, mutate, deny, error, skip or delay. The key point: no banking code changes to run an experiment.</a:t>
+              <a:t>Everything an agent does passes one of five checkpoints: request in, agent start, model call, tool action, result out. The checkpoints sit on a hook bus, and any plugin can watch or change what passes. Attacks inject a fault, failures simulate ordinary faults, defenses deny or redact, and observability records everything, always last. At each checkpoint a plugin can continue, mutate, deny, error, skip or delay. No banking code changes are needed to run an experiment.</a:t>
             </a:r>
           </a:p>
         </p:txBody>
@@ -1146,7 +1146,7 @@
           <a:lstStyle/>
           <a:p>
             <a:r>
-              <a:t>Here is what's been built from the start. The foundation was nine work packages: a frozen baseline of the original system with 49 regression tests, a modular runtime, YAML configuration, the hook bus, an observability pipeline, the first attack and fault plugins, scoring and benchmarks, a command-line workflow, and tests, docs and an open-source release. Since then: more exporters, three new banking workloads, a second institution, six defenses, a browser UI, and an extended scenario library. Seven hundred seventy offline tests back it.</a:t>
+              <a:t>The foundation was nine work packages: a frozen baseline of the original system with 49 regression tests, a modular runtime, YAML configuration, the hook bus, an observability pipeline, the first attack and fault plugins, scoring and benchmarks, a command-line workflow, and tests, docs and an open-source release. Since then: more exporters, three new banking workloads, a second institution, six defenses, a browser UI, and an extended scenario library. 770 offline tests back it.</a:t>
             </a:r>
           </a:p>
         </p:txBody>
@@ -1216,7 +1216,7 @@
           <a:lstStyle/>
           <a:p>
             <a:r>
-              <a:t>This is what we test against. A root agent routes each request to a front, mid or back office. Front office is customer-facing: transaction monitoring, chatbot, disputes. Mid office is operations planning, representative assist and loan pre-approval. Back office is end-of-day reconciliation and SAR escalation. That's 34 agents and 27 tools on a real banking service, so when a transfer runs, real state changes. Data is synthetic.</a:t>
+              <a:t>A root agent routes each request to a front, mid or back office. Front office is customer-facing: transaction monitoring, a chatbot, and disputes. Mid office covers operations planning, representative assist and loan pre-approval. Back office covers end-of-day reconciliation and SAR escalation. In total there are 34 agents and 27 tools on a real banking service, so when a transfer runs, real state changes. All data is synthetic.</a:t>
             </a:r>
           </a:p>
         </p:txBody>
@@ -1286,7 +1286,7 @@
           <a:lstStyle/>
           <a:p>
             <a:r>
-              <a:t>A complete experiment: the scenario, the attack plugin, where it attaches, and what a correct run looks like. This one hijacks a routing decision, so a suspicious transaction is quietly sent to the ordinary customer-service path. Four commands drive everything: validate, run, evaluate, and campaign to sweep a folder.</a:t>
+              <a:t>A complete experiment names the scenario, the attack plugin, where it attaches, and what a correct run looks like. This example hijacks a routing decision, so a suspicious transaction is quietly sent down the ordinary customer-service path. Four commands drive everything: validate checks every name against the live system, run executes the experiment, evaluate scores it against the baseline, and campaign sweeps a folder of configs into one report.</a:t>
             </a:r>
           </a:p>
         </p:txBody>
@@ -1356,7 +1356,7 @@
           <a:lstStyle/>
           <a:p>
             <a:r>
-              <a:t>Every run leaves a folder of evidence: a manifest that fingerprints the config and the model, a full trace, hook coverage, and a seven-dimension scorecard. The idea to take away: fired is not the same as succeeded. Here an attack rewrote a small transfer into five thousand dollars. It fired. The bank's own validation rejected it, so no money moved. We report those as two separate answers.</a:t>
+              <a:t>Every run leaves a folder of evidence: a manifest that fingerprints the configuration and the model, a full trace, hook coverage, and a seven-dimension scorecard. The key idea is that fired is not the same as succeeded. In the example, an attack rewrote a small transfer into five thousand dollars and fired, but the bank's own validation rejected it, so no money moved. The two answers are reported separately, and three event types keep attacks, defenses and ordinary faults from being confused.</a:t>
             </a:r>
           </a:p>
         </p:txBody>
@@ -1426,7 +1426,7 @@
           <a:lstStyle/>
           <a:p>
             <a:r>
-              <a:t>Five families. Prompt injection adds an instruction to an agent's model request. Message spoofing forges a message from a trusted colleague agent. Route confusion hijacks a hand-off. Tool mutation rewrites a real action's arguments just before it runs. And reliability faults simulate delays, timeouts and corrupted results. We kept faults separate from attacks on purpose. The extended library adds 26 variants across all three domains.</a:t>
+              <a:t>Five families. Prompt injection adds an instruction to an agent's model request. Message spoofing forges a message from a trusted colleague agent. Route confusion hijacks a hand-off. Tool mutation rewrites a real action's arguments just before it runs. Reliability faults simulate delays, timeouts and corrupted results. Faults are kept separate from attacks on purpose. The extended library adds 26 variants across all three domains.</a:t>
             </a:r>
           </a:p>
         </p:txBody>
@@ -1496,7 +1496,7 @@
           <a:lstStyle/>
           <a:p>
             <a:r>
-              <a:t>Each family was run five times against the live system. Prompt injection and message spoofing reached the model every time, and it resisted. The transfer mutation fired every time and the bank's own validation stopped it. Two results stand out: route confusion diverted a suspicious transaction away from compliance review every time, and the ledger attack posted to the wrong batch unnoticed. Faults were handled safely and logged as anomalies. All on gpt-oss-20b (open-weight), served through UF Navigator.</a:t>
+              <a:t>Each family was run five times against the live system. Prompt injection and message spoofing reached the model every time, and it resisted. The transfer mutation fired every time and the bank's own validation stopped it. Two results stand out: route confusion diverted a suspicious transaction away from compliance review every time, and the ledger attack posted to the wrong batch without being caught downstream. Faults were handled safely and logged as anomalies. All results use gpt-oss-20b (open-weight), served through UF Navigator.</a:t>
             </a:r>
           </a:p>
         </p:txBody>
@@ -11268,7 +11268,7 @@
                 </a:solidFill>
                 <a:latin typeface="Arial"/>
               </a:rPr>
-              <a:t>BEFORE THE CALL</a:t>
+              <a:t>BEFORE YOU RUN</a:t>
             </a:r>
           </a:p>
         </p:txBody>
@@ -11310,7 +11310,7 @@
                 </a:solidFill>
                 <a:latin typeface="Arial"/>
               </a:rPr>
-              <a:t>Backend up on port 8000; key in .env.</a:t>
+              <a:t>Backend up on port 8000; key in .env (or mock mode).</a:t>
             </a:r>
           </a:p>
           <a:p>
@@ -11329,7 +11329,7 @@
                 </a:solidFill>
                 <a:latin typeface="Arial"/>
               </a:rPr>
-              <a:t>Fallback: open a recorded run in the UI.</a:t>
+              <a:t>No key? Open a recorded run in the UI.</a:t>
             </a:r>
           </a:p>
         </p:txBody>

</xml_diff>

<commit_message>
docs: thorough pass -- fix stale test counts (823/846) and finish the Zero Trust toggle docs
README, GUIDE, RELEASE_CHECKLIST, CHANGELOG and Paper 2 all still said 770/
822/833 offline tests from before the regression-guard suite; now 823
(846 with the optional zero_trust dependency). README and the guide now
describe the dedicated zero_trust: toggle rather than only the generic
policies: form. docs/add_plugin.md gets a short section on
zero_trust_enforcement as a policy plugin that calls a real external
system rather than deciding anything itself. docs/ui.md documents the
Zero Trust fieldset as the one editor field not sourced from the live
registries. README's repo-structure tree now lists extensions/. The
2026-09-24 deck's TESTS stat is also corrected and regenerated.

Co-Authored-By: Claude Sonnet 5 <noreply@anthropic.com>
</commit_message>
<xml_diff>
--- a/presentations/MANTIS_Presentation_2026-09-24.pptx
+++ b/presentations/MANTIS_Presentation_2026-09-24.pptx
@@ -1146,7 +1146,7 @@
           <a:lstStyle/>
           <a:p>
             <a:r>
-              <a:t>The foundation was nine work packages: a frozen baseline of the original system with 49 regression tests, a modular runtime, YAML configuration, the hook bus, an observability pipeline, the first attack and fault plugins, scoring and benchmarks, a command-line workflow, and tests, docs and an open-source release. Since then: more exporters, three new banking workloads, a second institution, six defenses, a browser UI, and an extended scenario library. 770 offline tests back it.</a:t>
+              <a:t>The foundation was nine work packages: a frozen baseline of the original system with 49 regression tests, a modular runtime, YAML configuration, the hook bus, an observability pipeline, the first attack and fault plugins, scoring and benchmarks, a command-line workflow, and tests, docs and an open-source release. Since then: more exporters, three new banking workloads, a second institution, six defenses, a browser UI, and an extended scenario library. 823 offline tests back it.</a:t>
             </a:r>
           </a:p>
         </p:txBody>
@@ -16051,7 +16051,7 @@
                 </a:solidFill>
                 <a:latin typeface="Arial"/>
               </a:rPr>
-              <a:t>770</a:t>
+              <a:t>823</a:t>
             </a:r>
           </a:p>
         </p:txBody>

</xml_diff>